<commit_message>
Add niche-source synthesis; update deck with base-rate odds, Tmall rank and race counts; mark niche hunt done
Co-Authored-By: Claude Opus 5.5 <noreply@anthropic.com>
Claude-Session: https://claude.ai/code/session_01UTnW4B3cubTQp4NYZ2xN8G
</commit_message>
<xml_diff>
--- a/slides/pptx/Nike Short Thesis.pptx
+++ b/slides/pptx/Nike Short Thesis.pptx
@@ -121,14 +121,14 @@
   <p:extLst>
     <p:ext uri="{521415D9-36F7-43E2-AB2F-B90AF26B5E84}">
       <p14:sectionLst xmlns:p14="http://schemas.microsoft.com/office/powerpoint/2010/main">
-        <p14:section name="Recommendation" id="{8cabbabb-b518-677e-2d7b-0ac9c59cb13d}">
+        <p14:section name="Recommendation" id="{5ea5188c-fd3e-f2c7-83ca-1e83dfe0b5c6}">
           <p14:sldIdLst>
             <p14:sldId id="256"/>
             <p14:sldId id="257"/>
             <p14:sldId id="258"/>
           </p14:sldIdLst>
         </p14:section>
-        <p14:section name="Fundamentals and valuation" id="{7cba7521-067f-b6ea-2641-e8bf20e766f7}">
+        <p14:section name="Fundamentals and valuation" id="{bc454f24-cad7-9849-de93-04ca5aadffae}">
           <p14:sldIdLst>
             <p14:sldId id="259"/>
             <p14:sldId id="260"/>
@@ -136,7 +136,7 @@
             <p14:sldId id="262"/>
           </p14:sldIdLst>
         </p14:section>
-        <p14:section name="Evidence" id="{3126091c-dd3b-8fb1-41fc-94672efbee26}">
+        <p14:section name="Evidence" id="{970cf4a0-a17c-5b1f-1e95-bcacc007eb3b}">
           <p14:sldIdLst>
             <p14:sldId id="263"/>
             <p14:sldId id="264"/>
@@ -144,13 +144,13 @@
             <p14:sldId id="266"/>
           </p14:sldIdLst>
         </p14:section>
-        <p14:section name="Risks and catalysts" id="{9cf2ef53-8be3-abe7-13f9-fdb57af104cc}">
+        <p14:section name="Risks and catalysts" id="{ec7c108e-5344-2cc9-b661-8c87e1656f3c}">
           <p14:sldIdLst>
             <p14:sldId id="267"/>
             <p14:sldId id="268"/>
           </p14:sldIdLst>
         </p14:section>
-        <p14:section name="Appendix" id="{cae77758-b188-c4ee-cf54-832458652b1a}">
+        <p14:section name="Appendix" id="{8b215c64-60e0-54c1-326c-67d59642cb0a}">
           <p14:sldIdLst>
             <p14:sldId id="269"/>
             <p14:sldId id="270"/>
@@ -4403,7 +4403,7 @@
           <a:p>
             <a:r>
               <a:rPr lang="en-US" dirty="0"/>
-              <a:t>A reverse DCF starts from today's price and asks what long-run margin the market must assume. WACC is the yearly return investors demand; a higher WACC needs a higher margin. We show 8%, 9% and 10% because 9% and 10% both come from standard equity risk premium choices (Damodaran and Kroll). This is not a price target and no model is built yet. The 10-year average of 11.8% is our arithmetic on reported margins. Scoreboard caution: this supports 'FY28 and beyond is priced for a rebound', not 'the price assumes FY24 margins outright'.</a:t>
+              <a:t>A reverse DCF starts from today's price and asks what long-run margin the market must assume. WACC is the yearly return investors demand; a higher WACC needs a higher margin. We show 8%, 9% and 10% because 9% and 10% both come from standard equity risk premium choices (Damodaran and Kroll). This is not a price target and no model is built yet. Base rates: the Base Rate Book (Mauboussin and Callahan, 2016, printed p. 62) gives five-year operating margin persistence of 0.73 for consumer discretionary, which from 8.3% (FY26) implies about 9.0% to 9.4% by FY31; a skeptic check on a 73-company SEC panel found firms two or more points below their own 10-year mean regained 3.3 points 16% to 24% of the time, with brand leaders no better (1 of 11). The bull analog is adidas (6% to 11.3%, 2014 to 2019). At an 8% WACC, 9.4% is worth about $32.50, so the short needs a WACC of 9% or more. The 10-year average of 11.8% is our arithmetic on reported margins. Scoreboard caution: this supports 'FY28 and beyond is priced for a rebound', not 'the price assumes FY24 margins outright'.</a:t>
             </a:r>
             <a:endParaRPr lang="en-US" dirty="0"/>
           </a:p>
@@ -7779,7 +7779,7 @@
                           <a:ea typeface="Arial" pitchFamily="34" charset="-122"/>
                           <a:cs typeface="Arial" pitchFamily="34" charset="-120"/>
                         </a:rPr>
-                        <a:t>Real volume, but Pegasus 42 is marked down and growth lags ASICS and adidas; offsets lifestyle, not the FY28 gap</a:t>
+                        <a:t>Not visible in what runners wear: Hakone Ekiden Nike share 95.7% (2021) to 16.7% (2026); Running USA 2026 favorite racing shoe -4.2 pts. Growth may be distribution and lifestyle, not runners</a:t>
                       </a:r>
                       <a:endParaRPr lang="en-US" sz="1200" dirty="0">
                         <a:latin typeface="Arial" charset="0"/>
@@ -8562,7 +8562,7 @@
                 <a:ea typeface="Arial" pitchFamily="34" charset="-122"/>
                 <a:cs typeface="Arial" pitchFamily="34" charset="-120"/>
               </a:rPr>
-              <a:t>Sources: Dick's/Foot Locker review feed (Jun to Jul 2026); tariff gap sizing (USTR Section 301 notice, Jul 2026; Nike 10-Q); FINRA (Sep 30, 2026), Ortex, Interactive Brokers borrow data; SEC Form 4 and 13F data; guidance record (G9); USPTO trademark search (G7).</a:t>
+              <a:t>Sources: Dick's/Foot Locker review feed (Jun to Jul 2026); Alpen Group Hakone counts and Running USA Global Runner Survey (Oct 14, 2026) (N7); tariff gap sizing (USTR Section 301 notice, Jul 2026; Nike 10-Q); FINRA (Sep 30, 2026), Ortex, Interactive Brokers borrow data; SEC Form 4 and 13F data; guidance record (G9); USPTO trademark search (G7).</a:t>
             </a:r>
             <a:endParaRPr lang="en-US" sz="1000" dirty="0"/>
           </a:p>
@@ -12084,7 +12084,7 @@
                 <a:ea typeface="Arial" pitchFamily="34" charset="-122"/>
                 <a:cs typeface="Arial" pitchFamily="34" charset="-120"/>
               </a:rPr>
-              <a:t>A reverse DCF at a 9% to 10% required return needs a long-run operating margin of 11% to 14%; peer parity on P/E needs about 11.6%. Consensus has 7.2% in FY28; FY26 was 8.3% (6.2% without the tariff refund). On sales and EBITDA Nike already trades at the peer median, so the premium is only a margin bet.</a:t>
+              <a:t>A reverse DCF at a 9% to 10% required return needs a long-run operating margin of about 11% to 14%. Base rates (Mauboussin, Base Rate Book) put the expected FY31 margin near 9%; in a 73-company SEC panel, firms this far below their own average regained 3.3 points about one time in five. At 9.4% the same DCF gives $24 to $28. On sales and EBITDA Nike already trades at the peer median, so the premium is only a margin bet.</a:t>
             </a:r>
             <a:endParaRPr lang="en-US" sz="1300" dirty="0"/>
           </a:p>
@@ -12152,7 +12152,7 @@
                 <a:ea typeface="Arial" pitchFamily="34" charset="-122"/>
                 <a:cs typeface="Arial" pitchFamily="34" charset="-120"/>
               </a:rPr>
-              <a:t>Nike's two largest China partners closed 26% of doors in three years; Nike trails the European peer median by 14 to 18 points for eight quarters; nike.com visits fell 11% in August while adidas.com rose 12.5% and DICK'S rose 15%, so the digital decline is lost demand, not only a deliberate cut.</a:t>
+              <a:t>Nike fell from #1 to #3 on Tmall sports rankings (11.11 2025 and 618 2026, behind adidas and FILA); its two largest China partners closed 26% of doors; Nike trails the European peer median by 14 to 18 points for eight quarters; nike.com visits fell 11% in August while adidas.com rose 12.5% and DICK'S rose 15%, so the digital decline is lost demand, not only a deliberate cut.</a:t>
             </a:r>
             <a:endParaRPr lang="en-US" sz="1300" dirty="0"/>
           </a:p>
@@ -16783,7 +16783,7 @@
                 <a:ea typeface="Arial" pitchFamily="34" charset="-122"/>
                 <a:cs typeface="Arial" pitchFamily="34" charset="-120"/>
               </a:rPr>
-              <a:t>At $35.35 and 3% sales growth, a buyer earns about 9.0% a year only if margins settle at the 10-year average; at today's 8.3% it is about 7.2%.</a:t>
+              <a:t>Base rates put the expected FY31 margin near 9%, and companies this far below their own average regain 3.3 points about one time in five. At 9.4% the DCF gives $24 to $28.</a:t>
             </a:r>
             <a:endParaRPr lang="en-US" sz="1300" dirty="0"/>
           </a:p>
@@ -16822,7 +16822,7 @@
                 <a:ea typeface="Arial" pitchFamily="34" charset="-122"/>
                 <a:cs typeface="Arial" pitchFamily="34" charset="-120"/>
               </a:rPr>
-              <a:t>Sources: reverse DCF grid (22.5% tax, 3% revenue CAGR FY28 to FY36; range across growth assumptions), replicated cell by cell in repo; Nike FY24 and FY26 10-Ks; consensus (Oct 13, 2026). 10-year average is team arithmetic. Not a price target.</a:t>
+              <a:t>Sources: reverse DCF grid (22.5% tax, 3% revenue CAGR FY28 to FY36; range across growth assumptions), replicated cell by cell in repo; Nike FY24 and FY26 10-Ks; consensus (Oct 13, 2026); Base Rate Book (2016) p. 62 and SEC panel (research_notes/Niche sources/N8 and N8_check). Not a price target.</a:t>
             </a:r>
             <a:endParaRPr lang="en-US" sz="1000" dirty="0"/>
           </a:p>
@@ -18135,7 +18135,7 @@
                 <a:ea typeface="Arial" pitchFamily="34" charset="-122"/>
                 <a:cs typeface="Arial" pitchFamily="34" charset="-120"/>
               </a:rPr>
-              <a:t>65% to 50%</a:t>
+              <a:t>#1 to #3</a:t>
             </a:r>
             <a:endParaRPr lang="en-US" sz="2800" dirty="0"/>
           </a:p>
@@ -18174,7 +18174,7 @@
                 <a:ea typeface="Arial" pitchFamily="34" charset="-122"/>
                 <a:cs typeface="Arial" pitchFamily="34" charset="-120"/>
               </a:rPr>
-              <a:t>Nike's share of a 14-company China peer set, 2022 to H1 2026.</a:t>
+              <a:t>Nike's rank on Tmall sports lists: first every festival 2019 to 11.11 2024, third at 11.11 2025 and 618 2026, behind adidas and FILA.</a:t>
             </a:r>
             <a:endParaRPr lang="en-US" sz="1200" dirty="0"/>
           </a:p>
@@ -18291,7 +18291,7 @@
                 <a:ea typeface="Arial" pitchFamily="34" charset="-122"/>
                 <a:cs typeface="Arial" pitchFamily="34" charset="-120"/>
               </a:rPr>
-              <a:t>Sources: HKEX annual and interim reports (Topsports 6110, Pou Sheng 3813, ANTA, Li-Ning, Xtep, 361 Degrees) through Jun 2026; Nike Q1 FY27 10-Q; FY24 and FY26 10-Ks. No source counts Nike-only doors; partners also sell adidas. Topsports reports Aug 2026 doors on Oct 28.</a:t>
+              <a:t>Sources: Tmall festival rankings and Guosen Securities platform data (research_notes/Niche sources/N5); HKEX annual and interim reports (Topsports 6110, Pou Sheng 3813, ANTA, Li-Ning, Xtep, 361 Degrees) through Jun 2026; Nike Q1 FY27 10-Q; FY24 and FY26 10-Ks. No source counts Nike-only doors; partners also sell adidas. Topsports reports Aug 2026 doors on Oct 28.</a:t>
             </a:r>
             <a:endParaRPr lang="en-US" sz="1000" dirty="0"/>
           </a:p>

</xml_diff>

<commit_message>
Add wave 3 synthesis; update catalysts with Topsports dates, nowcast and CFO record; mark wave 3 done
Co-Authored-By: Claude Opus 5.5 <noreply@anthropic.com>
Claude-Session: https://claude.ai/code/session_01UTnW4B3cubTQp4NYZ2xN8G
</commit_message>
<xml_diff>
--- a/slides/pptx/Nike Short Thesis.pptx
+++ b/slides/pptx/Nike Short Thesis.pptx
@@ -121,14 +121,14 @@
   <p:extLst>
     <p:ext uri="{521415D9-36F7-43E2-AB2F-B90AF26B5E84}">
       <p14:sectionLst xmlns:p14="http://schemas.microsoft.com/office/powerpoint/2010/main">
-        <p14:section name="Recommendation" id="{5ea5188c-fd3e-f2c7-83ca-1e83dfe0b5c6}">
+        <p14:section name="Recommendation" id="{d10599f1-4e84-1711-85cc-c2287a193e85}">
           <p14:sldIdLst>
             <p14:sldId id="256"/>
             <p14:sldId id="257"/>
             <p14:sldId id="258"/>
           </p14:sldIdLst>
         </p14:section>
-        <p14:section name="Fundamentals and valuation" id="{bc454f24-cad7-9849-de93-04ca5aadffae}">
+        <p14:section name="Fundamentals and valuation" id="{d928c699-5b7d-c853-2785-772d950fda2f}">
           <p14:sldIdLst>
             <p14:sldId id="259"/>
             <p14:sldId id="260"/>
@@ -136,7 +136,7 @@
             <p14:sldId id="262"/>
           </p14:sldIdLst>
         </p14:section>
-        <p14:section name="Evidence" id="{970cf4a0-a17c-5b1f-1e95-bcacc007eb3b}">
+        <p14:section name="Evidence" id="{f212fbca-2466-1276-df01-f7a8b7bbd41b}">
           <p14:sldIdLst>
             <p14:sldId id="263"/>
             <p14:sldId id="264"/>
@@ -144,13 +144,13 @@
             <p14:sldId id="266"/>
           </p14:sldIdLst>
         </p14:section>
-        <p14:section name="Risks and catalysts" id="{ec7c108e-5344-2cc9-b661-8c87e1656f3c}">
+        <p14:section name="Risks and catalysts" id="{b642981a-00e0-9e4a-4c01-b49b05148c48}">
           <p14:sldIdLst>
             <p14:sldId id="267"/>
             <p14:sldId id="268"/>
           </p14:sldIdLst>
         </p14:section>
-        <p14:section name="Appendix" id="{8b215c64-60e0-54c1-326c-67d59642cb0a}">
+        <p14:section name="Appendix" id="{5ee75705-db09-d794-cdba-e9c84a0025c7}">
           <p14:sldIdLst>
             <p14:sldId id="269"/>
             <p14:sldId id="270"/>
@@ -3787,7 +3787,7 @@
           <a:p>
             <a:r>
               <a:rPr lang="en-US" dirty="0"/>
-              <a:t>Decision rules written in advance. Investor Day: a dated long-term operating margin target of 13% or more with an interim bridge would falsify the margin argument; an undated target or one below about 12% supports it. Feng Tay October revenue is published on Taiwan's MOPS around the 10th of each month; thresholds are on a two-year US-dollar basis. Q2 FY27 results arrive around Dec 17, after finals. The dividend is usually declared between Nov 14 and 20; a freeze or token raise is the likely outcome and a mild positive; a large raise would work against us.</a:t>
+              <a:t>Decision rules written in advance. CFO Denton record (Wave 3 W2): across Lowe's, CVS and Pfizer, 0 of 7 targets were above consensus and 10 of 12 guides were met; in-line guides rallied about 5% the next day, but 7 of 8 came with buybacks or dividend raises, which Nike has paused. Supplier read (W3): Feng Tay says Nike momentum is flat and 2027 orders are still being negotiated. Investor Day: a dated long-term operating margin target of 13% or more with an interim bridge would falsify the margin argument; an undated target or one below about 12% supports it. Feng Tay October revenue is published on Taiwan's MOPS around the 10th of each month; thresholds are on a two-year US-dollar basis. Q2 FY27 results arrive around Dec 17, after finals. The dividend is usually declared between Nov 14 and 20; a freeze or token raise is the likely outcome and a mild positive; a large raise would work against us.</a:t>
             </a:r>
             <a:endParaRPr lang="en-US" dirty="0"/>
           </a:p>
@@ -8906,7 +8906,7 @@
                           <a:ea typeface="Arial" pitchFamily="34" charset="-122"/>
                           <a:cs typeface="Arial" pitchFamily="34" charset="-120"/>
                         </a:rPr>
-                        <a:t>Oct 28</a:t>
+                        <a:t>Oct 21 to 28</a:t>
                       </a:r>
                       <a:endParaRPr lang="en-US" sz="1200" dirty="0">
                         <a:latin typeface="Arial" charset="0"/>
@@ -8953,7 +8953,7 @@
                           <a:ea typeface="Arial" pitchFamily="34" charset="-122"/>
                           <a:cs typeface="Arial" pitchFamily="34" charset="-120"/>
                         </a:rPr>
-                        <a:t>Topsports interim results</a:t>
+                        <a:t>Topsports quarterly update and interim results</a:t>
                       </a:r>
                       <a:endParaRPr lang="en-US" sz="1200" dirty="0">
                         <a:latin typeface="Arial" charset="0"/>
@@ -9000,7 +9000,7 @@
                           <a:ea typeface="Arial" pitchFamily="34" charset="-122"/>
                           <a:cs typeface="Arial" pitchFamily="34" charset="-120"/>
                         </a:rPr>
-                        <a:t>Door decline continues; China wholesale weak</a:t>
+                        <a:t>Jun to Aug sales low-teens down or worse; our China Q2 nowcast is -19% to -32%</a:t>
                       </a:r>
                       <a:endParaRPr lang="en-US" sz="1200" dirty="0">
                         <a:latin typeface="Arial" charset="0"/>
@@ -9047,7 +9047,7 @@
                           <a:ea typeface="Arial" pitchFamily="34" charset="-122"/>
                           <a:cs typeface="Arial" pitchFamily="34" charset="-120"/>
                         </a:rPr>
-                        <a:t>Doors stabilize</a:t>
+                        <a:t>Mid-single-digit decline or better</a:t>
                       </a:r>
                       <a:endParaRPr lang="en-US" sz="1200" dirty="0">
                         <a:latin typeface="Arial" charset="0"/>
@@ -9570,7 +9570,7 @@
                           <a:ea typeface="Arial" pitchFamily="34" charset="-122"/>
                           <a:cs typeface="Arial" pitchFamily="34" charset="-120"/>
                         </a:rPr>
-                        <a:t>FY28 EPS framed below about $1.50, or revenue below flat</a:t>
+                        <a:t>No dated margin target, or one below about 12%; the CFO set 0 of 7 targets above consensus at Lowe's, CVS and Pfizer</a:t>
                       </a:r>
                       <a:endParaRPr lang="en-US" sz="1200" dirty="0">
                         <a:latin typeface="Arial" charset="0"/>
@@ -9617,7 +9617,7 @@
                           <a:ea typeface="Arial" pitchFamily="34" charset="-122"/>
                           <a:cs typeface="Arial" pitchFamily="34" charset="-120"/>
                         </a:rPr>
-                        <a:t>FY28 held, plus FY29 margin target above about 9%</a:t>
+                        <a:t>Dated EBIT margin target of 13% or more with a bridge</a:t>
                       </a:r>
                       <a:endParaRPr lang="en-US" sz="1200" dirty="0">
                         <a:latin typeface="Arial" charset="0"/>

</xml_diff>